<commit_message>
feat(llm): support active Gemini 3.6 Flash and Groq models with resilient fallback and modern UI
</commit_message>
<xml_diff>
--- a/Microservice_Code_Studio_Presentacion.pptx
+++ b/Microservice_Code_Studio_Presentacion.pptx
@@ -1161,7 +1161,7 @@
               <a:buNone/>
             </a:pPr>
             <a:r>
-              <a:rPr lang="en-US" sz="4200" b="1" dirty="0">
+              <a:rPr lang="en-US" sz="4000" b="1" dirty="0">
                 <a:solidFill>
                   <a:srgbClr val="F7FAFC"/>
                 </a:solidFill>
@@ -1176,7 +1176,7 @@
               <a:buNone/>
             </a:pPr>
             <a:r>
-              <a:rPr lang="en-US" sz="3400" b="1" dirty="0">
+              <a:rPr lang="en-US" sz="3200" b="1" dirty="0">
                 <a:solidFill>
                   <a:srgbClr val="F7FAFC"/>
                 </a:solidFill>
@@ -4862,8 +4862,8 @@
         </p:nvSpPr>
         <p:spPr>
           <a:xfrm>
-            <a:off x="6291072" y="2084832"/>
-            <a:ext cx="2834640" cy="256032"/>
+            <a:off x="6263640" y="2011680"/>
+            <a:ext cx="3886200" cy="320040"/>
           </a:xfrm>
           <a:prstGeom prst="rect">
             <a:avLst/>
@@ -4885,7 +4885,7 @@
                 </a:solidFill>
                 <a:latin typeface="Century Gothic"/>
               </a:rPr>
-              <a:t>La Solución: Microservice Code Studio</a:t>
+              <a:t>Microservice Code Studio</a:t>
             </a:r>
             <a:r>
               <a:rPr lang="en-US" sz="1600" b="1" dirty="0" err="1">
@@ -4981,7 +4981,7 @@
                 <a:buNone/>
               </a:pPr>
               <a:r>
-                <a:rPr lang="en-US" sz="750" b="1" dirty="0">
+                <a:rPr lang="en-US" sz="800" b="1" dirty="0">
                   <a:solidFill>
                     <a:srgbClr val="F7FAFC"/>
                   </a:solidFill>
@@ -5075,7 +5075,7 @@
                 <a:buNone/>
               </a:pPr>
               <a:r>
-                <a:rPr sz="750">
+                <a:rPr sz="800" b="1">
                   <a:solidFill>
                     <a:srgbClr val="F7FAFC"/>
                   </a:solidFill>
@@ -5195,7 +5195,7 @@
                 <a:buNone/>
               </a:pPr>
               <a:r>
-                <a:rPr lang="en-US" sz="750" b="1" dirty="0" err="1">
+                <a:rPr lang="en-US" sz="800" b="1" dirty="0" err="1">
                   <a:solidFill>
                     <a:srgbClr val="F7FAFC"/>
                   </a:solidFill>
@@ -5335,7 +5335,7 @@
                 <a:buNone/>
               </a:pPr>
               <a:r>
-                <a:rPr lang="en-US" sz="750" b="1" dirty="0" err="1">
+                <a:rPr lang="en-US" sz="800" b="1" dirty="0" err="1">
                   <a:solidFill>
                     <a:srgbClr val="F7FAFC"/>
                   </a:solidFill>
@@ -5584,8 +5584,8 @@
         </p:nvSpPr>
         <p:spPr>
           <a:xfrm>
-            <a:off x="6291072" y="2359152"/>
-            <a:ext cx="3794760" cy="3267456"/>
+            <a:off x="6263640" y="2395728"/>
+            <a:ext cx="3840480" cy="3154680"/>
           </a:xfrm>
           <a:prstGeom prst="rect">
             <a:avLst/>
@@ -5595,7 +5595,7 @@
         </p:spPr>
         <p:txBody>
           <a:bodyPr wrap="square" lIns="0" tIns="0" rIns="0" bIns="0" rtlCol="0" anchor="t">
-            <a:normAutofit fontScale="62500" lnSpcReduction="20000"/>
+            <a:noAutofit/>
           </a:bodyPr>
           <a:lstStyle/>
           <a:p>
@@ -5604,17 +5604,17 @@
                 <a:spcPct val="90000"/>
               </a:lnSpc>
               <a:spcBef>
-                <a:spcPts val="200"/>
+                <a:spcPts val="500"/>
               </a:spcBef>
               <a:tabLst/>
               <a:defRPr/>
               <a:spcAft>
-                <a:spcPts val="100"/>
+                <a:spcPts val="200"/>
               </a:spcAft>
               <a:buNone/>
             </a:pPr>
             <a:r>
-              <a:rPr kumimoji="0" lang="es-PE" sz="1150" b="1" i="0" u="none" strike="noStrike" kern="1200" cap="none" spc="0" normalizeH="0" baseline="0" noProof="0" dirty="0">
+              <a:rPr kumimoji="0" lang="es-PE" sz="1000" b="1" i="0" u="none" strike="noStrike" kern="1200" cap="none" spc="0" normalizeH="0" baseline="0" noProof="0" dirty="0">
                 <a:ln>
                   <a:noFill/>
                 </a:ln>
@@ -5628,7 +5628,16 @@
                 <a:ea typeface="+mn-ea"/>
                 <a:cs typeface="+mn-cs"/>
               </a:rPr>
-              <a:t>Capacidades del sistema web en producción:</a:t>
+              <a:t>• Inicio Rápido &amp; Auto-Pilot: </a:t>
+            </a:r>
+            <a:r>
+              <a:rPr sz="950" b="0">
+                <a:solidFill>
+                  <a:srgbClr val="D1D5DB"/>
+                </a:solidFill>
+                <a:latin typeface="Century Gothic"/>
+              </a:rPr>
+              <a:t>Síntesis autónoma 1-Click o modo asistido con controles hot-pause, resume y cancel en caliente.</a:t>
             </a:r>
           </a:p>
           <a:p>
@@ -5637,23 +5646,32 @@
                 <a:spcPct val="90000"/>
               </a:lnSpc>
               <a:spcBef>
-                <a:spcPts val="200"/>
+                <a:spcPts val="500"/>
               </a:spcBef>
               <a:tabLst/>
               <a:defRPr/>
               <a:spcAft>
-                <a:spcPts val="100"/>
+                <a:spcPts val="200"/>
               </a:spcAft>
               <a:buNone/>
             </a:pPr>
             <a:r>
-              <a:rPr sz="900" b="0">
+              <a:rPr sz="1000" b="1">
                 <a:solidFill>
                   <a:srgbClr val="F7FAFC"/>
                 </a:solidFill>
                 <a:latin typeface="Century Gothic"/>
               </a:rPr>
-              <a:t>• Inicio Rápido 1-Click &amp; Auto-Pilot: Síntesis autónoma desatendida o modo asistido con pausa/reanudar en caliente.</a:t>
+              <a:t>• Ingesta Dual BDD (Spec Kit): </a:t>
+            </a:r>
+            <a:r>
+              <a:rPr sz="950" b="0">
+                <a:solidFill>
+                  <a:srgbClr val="D1D5DB"/>
+                </a:solidFill>
+                <a:latin typeface="Century Gothic"/>
+              </a:rPr>
+              <a:t>Carga de spec.md o JSON blueprint con validación formal de criterios Given/When/Then.</a:t>
             </a:r>
             <a:endParaRPr kumimoji="0" lang="es-PE" sz="1700" b="0" i="0" u="none" strike="noStrike" kern="1200" cap="none" spc="0" normalizeH="0" baseline="0" noProof="0" dirty="0">
               <a:ln>
@@ -5676,17 +5694,17 @@
                 <a:spcPct val="90000"/>
               </a:lnSpc>
               <a:spcBef>
-                <a:spcPts val="200"/>
+                <a:spcPts val="500"/>
               </a:spcBef>
               <a:tabLst/>
               <a:defRPr/>
               <a:spcAft>
-                <a:spcPts val="100"/>
+                <a:spcPts val="200"/>
               </a:spcAft>
               <a:buNone/>
             </a:pPr>
             <a:r>
-              <a:rPr kumimoji="0" lang="es-PE" sz="900" b="0" i="0" u="none" strike="noStrike" kern="1200" cap="none" spc="0" normalizeH="0" baseline="0" noProof="0" dirty="0">
+              <a:rPr kumimoji="0" lang="es-PE" sz="1000" b="1" i="0" u="none" strike="noStrike" kern="1200" cap="none" spc="0" normalizeH="0" baseline="0" noProof="0" dirty="0">
                 <a:ln>
                   <a:noFill/>
                 </a:ln>
@@ -5700,7 +5718,16 @@
                 <a:ea typeface="+mn-ea"/>
                 <a:cs typeface="+mn-cs"/>
               </a:rPr>
-              <a:t>• Ingesta Dual de Especificaciones: Carga de spec.md (Spec Kit) o payload REST JSON con validación BDD Given/When/Then.</a:t>
+              <a:t>• Arquitectura 4 Capas &amp; JPA: </a:t>
+            </a:r>
+            <a:r>
+              <a:rPr sz="950" b="0">
+                <a:solidFill>
+                  <a:srgbClr val="D1D5DB"/>
+                </a:solidFill>
+                <a:latin typeface="Century Gothic"/>
+              </a:rPr>
+              <a:t>Topología limpia (Controller➔Service➔Repo➔Model), DTOs Java Records inmutables y scripts SQL sincronizados.</a:t>
             </a:r>
           </a:p>
           <a:p>
@@ -5709,23 +5736,32 @@
                 <a:spcPct val="90000"/>
               </a:lnSpc>
               <a:spcBef>
-                <a:spcPts val="200"/>
+                <a:spcPts val="500"/>
               </a:spcBef>
               <a:tabLst/>
               <a:defRPr/>
               <a:spcAft>
-                <a:spcPts val="100"/>
+                <a:spcPts val="200"/>
               </a:spcAft>
               <a:buNone/>
             </a:pPr>
             <a:r>
-              <a:rPr sz="900" b="0">
+              <a:rPr sz="1000" b="1">
                 <a:solidFill>
                   <a:srgbClr val="F7FAFC"/>
                 </a:solidFill>
                 <a:latin typeface="Century Gothic"/>
               </a:rPr>
-              <a:t>• Arquitectura 4 Capas &amp; Mermaid: Diagrama jerárquico (Controller ➔ Service ➔ Repo ➔ Model) y ERD relacional interactivo.</a:t>
+              <a:t>• Sandbox Hermético Offline: </a:t>
+            </a:r>
+            <a:r>
+              <a:rPr sz="950" b="0">
+                <a:solidFill>
+                  <a:srgbClr val="D1D5DB"/>
+                </a:solidFill>
+                <a:latin typeface="Century Gothic"/>
+              </a:rPr>
+              <a:t>Compilación y pruebas Mockito con --network none contra caché .m2 de solo lectura inmutable.</a:t>
             </a:r>
             <a:endParaRPr kumimoji="0" lang="es-PE" sz="1500" b="0" i="0" u="none" strike="noStrike" kern="1200" cap="none" spc="0" normalizeH="0" baseline="0" noProof="0" dirty="0">
               <a:ln>
@@ -5748,17 +5784,17 @@
                 <a:spcPct val="90000"/>
               </a:lnSpc>
               <a:spcBef>
-                <a:spcPts val="200"/>
+                <a:spcPts val="500"/>
               </a:spcBef>
               <a:tabLst/>
               <a:defRPr/>
               <a:spcAft>
-                <a:spcPts val="100"/>
+                <a:spcPts val="200"/>
               </a:spcAft>
               <a:buNone/>
             </a:pPr>
             <a:r>
-              <a:rPr kumimoji="0" lang="es-PE" sz="900" b="0" i="0" u="none" strike="noStrike" kern="1200" cap="none" spc="0" normalizeH="0" baseline="0" noProof="0" dirty="0">
+              <a:rPr kumimoji="0" lang="es-PE" sz="1000" b="1" i="0" u="none" strike="noStrike" kern="1200" cap="none" spc="0" normalizeH="0" baseline="0" noProof="0" dirty="0">
                 <a:ln>
                   <a:noFill/>
                 </a:ln>
@@ -5772,7 +5808,16 @@
                 <a:ea typeface="+mn-ea"/>
                 <a:cs typeface="+mn-cs"/>
               </a:rPr>
-              <a:t>• Entidades JPA &amp; DDL Sincronizado: Jakarta Persistence fuertemente tipado con scripts sincronizados schema.sql y data.sql.</a:t>
+              <a:t>• Auto-Reparación Acotada (3x): </a:t>
+            </a:r>
+            <a:r>
+              <a:rPr sz="950" b="0">
+                <a:solidFill>
+                  <a:srgbClr val="D1D5DB"/>
+                </a:solidFill>
+                <a:latin typeface="Century Gothic"/>
+              </a:rPr>
+              <a:t>Diagnóstico automático de trazas Maven con auto-parcheo de código antes de escalar a HITL.</a:t>
             </a:r>
           </a:p>
           <a:p>
@@ -5781,167 +5826,32 @@
                 <a:spcPct val="90000"/>
               </a:lnSpc>
               <a:spcBef>
-                <a:spcPts val="200"/>
+                <a:spcPts val="500"/>
               </a:spcBef>
               <a:tabLst/>
               <a:defRPr/>
               <a:spcAft>
-                <a:spcPts val="100"/>
+                <a:spcPts val="200"/>
               </a:spcAft>
               <a:buNone/>
             </a:pPr>
             <a:r>
-              <a:rPr sz="900" b="0">
+              <a:rPr sz="1000" b="1">
                 <a:solidFill>
                   <a:srgbClr val="F7FAFC"/>
                 </a:solidFill>
                 <a:latin typeface="Century Gothic"/>
               </a:rPr>
-              <a:t>• Sandbox Hermético Offline: Verificación en contenedor Docker con red desconectada y caché .m2 inmutable contra alucinaciones.</a:t>
-            </a:r>
-            <a:endParaRPr kumimoji="0" lang="es-PE" sz="1500" b="0" i="0" u="none" strike="noStrike" kern="1200" cap="none" spc="0" normalizeH="0" baseline="0" noProof="0" dirty="0">
-              <a:ln>
-                <a:noFill/>
-              </a:ln>
-              <a:solidFill>
-                <a:prstClr val="white"/>
-              </a:solidFill>
-              <a:effectLst/>
-              <a:uLnTx/>
-              <a:uFillTx/>
-              <a:latin typeface="Century Gothic" panose="020B0502020202020204"/>
-              <a:ea typeface="+mn-ea"/>
-              <a:cs typeface="+mn-cs"/>
-            </a:endParaRPr>
-          </a:p>
-          <a:p>
-            <a:pPr marR="0" algn="l" defTabSz="914400" rtl="0" eaLnBrk="1" fontAlgn="auto" latinLnBrk="0" hangingPunct="1">
-              <a:lnSpc>
-                <a:spcPct val="90000"/>
-              </a:lnSpc>
-              <a:spcBef>
-                <a:spcPts val="200"/>
-              </a:spcBef>
-              <a:tabLst/>
-              <a:defRPr/>
-              <a:spcAft>
-                <a:spcPts val="100"/>
-              </a:spcAft>
-              <a:buNone/>
-            </a:pPr>
-            <a:r>
-              <a:rPr kumimoji="0" lang="es-PE" sz="900" b="0" i="0" u="none" strike="noStrike" kern="1200" cap="none" spc="0" normalizeH="0" baseline="0" noProof="0" dirty="0">
-                <a:ln>
-                  <a:noFill/>
-                </a:ln>
-                <a:solidFill>
-                  <a:srgbClr val="F7FAFC"/>
-                </a:solidFill>
-                <a:effectLst/>
-                <a:uLnTx/>
-                <a:uFillTx/>
-                <a:latin typeface="Century Gothic" panose="020B0502020202020204"/>
-                <a:ea typeface="+mn-ea"/>
-                <a:cs typeface="+mn-cs"/>
-              </a:rPr>
-              <a:t>• Auto-Reparación Acotada (3x): Parser de errores de compilación Maven que reintenta hasta 3 parches antes de solicitar HITL.</a:t>
-            </a:r>
-          </a:p>
-          <a:p>
-            <a:pPr marR="0" algn="l" defTabSz="914400" rtl="0" eaLnBrk="1" fontAlgn="auto" latinLnBrk="0" hangingPunct="1">
-              <a:lnSpc>
-                <a:spcPct val="90000"/>
-              </a:lnSpc>
-              <a:spcBef>
-                <a:spcPts val="200"/>
-              </a:spcBef>
-              <a:tabLst/>
-              <a:defRPr/>
-              <a:spcAft>
-                <a:spcPts val="100"/>
-              </a:spcAft>
-              <a:buNone/>
-            </a:pPr>
-            <a:r>
-              <a:rPr sz="900" b="0">
-                <a:solidFill>
-                  <a:srgbClr val="F7FAFC"/>
-                </a:solidFill>
-                <a:latin typeface="Century Gothic"/>
-              </a:rPr>
-              <a:t>• Auditoría SAST &amp; Quality Gate: Análisis estático de código, detección de secretos, métricas CC y auto-parcheo 1-clic.</a:t>
-            </a:r>
-            <a:endParaRPr kumimoji="0" lang="es-PE" sz="1500" b="0" i="0" u="none" strike="noStrike" kern="1200" cap="none" spc="0" normalizeH="0" baseline="0" noProof="0" dirty="0">
-              <a:ln>
-                <a:noFill/>
-              </a:ln>
-              <a:solidFill>
-                <a:prstClr val="white"/>
-              </a:solidFill>
-              <a:effectLst/>
-              <a:uLnTx/>
-              <a:uFillTx/>
-              <a:latin typeface="Century Gothic" panose="020B0502020202020204"/>
-              <a:ea typeface="+mn-ea"/>
-              <a:cs typeface="+mn-cs"/>
-            </a:endParaRPr>
-          </a:p>
-          <a:p>
-            <a:pPr marR="0" algn="l" defTabSz="914400" rtl="0" eaLnBrk="1" fontAlgn="auto" latinLnBrk="0" hangingPunct="1">
-              <a:lnSpc>
-                <a:spcPct val="90000"/>
-              </a:lnSpc>
-              <a:spcBef>
-                <a:spcPts val="200"/>
-              </a:spcBef>
-              <a:tabLst/>
-              <a:defRPr/>
-              <a:spcAft>
-                <a:spcPts val="100"/>
-              </a:spcAft>
-              <a:buNone/>
-            </a:pPr>
-            <a:r>
-              <a:rPr kumimoji="0" lang="es-PE" sz="900" b="0" i="0" u="none" strike="noStrike" kern="1200" cap="none" spc="0" normalizeH="0" baseline="0" noProof="0" dirty="0">
-                <a:ln>
-                  <a:noFill/>
-                </a:ln>
-                <a:solidFill>
-                  <a:srgbClr val="F7FAFC"/>
-                </a:solidFill>
-                <a:effectLst/>
-                <a:uLnTx/>
-                <a:uFillTx/>
-                <a:latin typeface="Century Gothic" panose="020B0502020202020204"/>
-                <a:ea typeface="+mn-ea"/>
-                <a:cs typeface="+mn-cs"/>
-              </a:rPr>
-              <a:t>• DevOps &amp; Despliegue Multi-Cloud: Dockerfile multi-stage, Docker Compose, pipelines CI/CD (GitHub/GitLab) y Kubernetes.</a:t>
-            </a:r>
-          </a:p>
-          <a:p>
-            <a:pPr marR="0" algn="l" defTabSz="914400" rtl="0" eaLnBrk="1" fontAlgn="auto" latinLnBrk="0" hangingPunct="1">
-              <a:lnSpc>
-                <a:spcPct val="90000"/>
-              </a:lnSpc>
-              <a:spcBef>
-                <a:spcPts val="200"/>
-              </a:spcBef>
-              <a:tabLst/>
-              <a:defRPr/>
-              <a:spcAft>
-                <a:spcPts val="100"/>
-              </a:spcAft>
-              <a:buNone/>
-            </a:pPr>
-            <a:r>
-              <a:rPr sz="900" b="0">
-                <a:solidFill>
-                  <a:srgbClr val="F7FAFC"/>
-                </a:solidFill>
-                <a:latin typeface="Century Gothic"/>
-              </a:rPr>
-              <a:t>• Exportación ZIP &amp; Publicación Git: Descarga de bundle completo y push atómico a rama remota con credenciales efímeras.</a:t>
+              <a:t>• Quality Gate SAST &amp; DevOps: </a:t>
+            </a:r>
+            <a:r>
+              <a:rPr sz="950" b="0">
+                <a:solidFill>
+                  <a:srgbClr val="D1D5DB"/>
+                </a:solidFill>
+                <a:latin typeface="Century Gothic"/>
+              </a:rPr>
+              <a:t>Cero secretos persistidos, reporte estático 100/100, Dockerfile multi-stage, Compose y K8s.</a:t>
             </a:r>
             <a:endParaRPr kumimoji="0" lang="es-PE" sz="1500" b="0" i="0" u="none" strike="noStrike" kern="1200" cap="none" spc="0" normalizeH="0" baseline="0" noProof="0" dirty="0">
               <a:ln>

</xml_diff>